<commit_message>
Router: correct the capped estimate against a scrambled-history baseline; add verification scripts
</commit_message>
<xml_diff>
--- a/deck/Odysse_deck.pptx
+++ b/deck/Odysse_deck.pptx
@@ -692,7 +692,7 @@
           <a:p>
             <a:r>
               <a:rPr lang="en-US" dirty="0"/>
-              <a:t>Close on the 61%: not the trips, stable per driver, opposite preferences, a lever worth 1–2 points before touching no-responses, test it. Then the EV question, the limits, and stop.</a:t>
+              <a:t>Close on the 61%: not the trips, stable per driver, opposite preferences. The lever is evidenced by the held-out test, not by the router; the pound figure is a conversion rate, not a claim. Then the EV question, the limits, and stop.</a:t>
             </a:r>
             <a:endParaRPr lang="en-US" dirty="0"/>
           </a:p>
@@ -1660,7 +1660,7 @@
           <a:p>
             <a:r>
               <a:rPr lang="en-US" dirty="0"/>
-              <a:t>Say the correction unprompted, and the like-for-like result. Then point to where the matching evidence sits: the held-out turn-down result and the driver-visible profile. The A/B test settles ranking vs matching. If asked about 32% vs 44%: that sanity check is on the uncapped router, which moves 38% of offers.</a:t>
+              <a:t>Say both corrections unprompted. The second one I found on the morning of the interview by running the scrambled router through the capped pipeline for the first time. Then move the weight onto slide 7: that is where the lever is evidenced. If asked about 32% vs 44%: that sanity check is on the UNCAPPED router, which moves 38% of offers.</a:t>
             </a:r>
             <a:endParaRPr lang="en-US" dirty="0"/>
           </a:p>
@@ -2908,7 +2908,7 @@
                 <a:ea typeface="Calibri" pitchFamily="34" charset="-122"/>
                 <a:cs typeface="Calibri" pitchFamily="34" charset="-120"/>
               </a:rPr>
-              <a:t>It isn't explained by the trips, each driver's pattern is stable, and drivers differ in which trips suit them. That is a lever dispatch isn't pulling. Routing on it is worth about 1–2 points of acceptance across all offers in the offline test — roughly 56–112 more accepted offers over a six-day window like this one, about £700–1,400 in gross fares. It looks small because it can only act where a second driver is free: on the offers it does move, acceptance rises about 8 to 16 points. Whether matching on the trip beats a plain ranking is the open question the A/B test answers.</a:t>
+              <a:t>It isn't explained by the trips, each driver's pattern is stable, and drivers differ in which trips suit them — in opposite directions, so the fleet average hides it. That is a lever dispatch isn't pulling. My prototype router shows the mechanism but cannot size it: against a scrambled-history baseline the offline gain is about two tenths of a point, which I won't quote as a result. For scale, each point of acceptance is worth roughly 56 more accepted offers and £700 in gross fares over a six-day window like this one — which is why the A/B test is worth running.</a:t>
             </a:r>
             <a:endParaRPr lang="en-US" sz="1500" dirty="0"/>
           </a:p>
@@ -3214,7 +3214,7 @@
                 <a:ea typeface="Calibri" pitchFamily="34" charset="-122"/>
                 <a:cs typeface="Calibri" pitchFamily="34" charset="-120"/>
               </a:rPr>
-              <a:t>8–16 points on moved offers = the 1.2–2.4 point average ÷ the 15% of offers that move.</a:t>
+              <a:t>Router, held workload, graded by the other model: real +1.15, 20 scrambled rebuilds +0.95 on average. Difference +0.2, inside the scrambled range.</a:t>
             </a:r>
             <a:endParaRPr lang="en-US" sz="950" dirty="0"/>
           </a:p>
@@ -8360,7 +8360,7 @@
                 <a:ea typeface="Calibri" pitchFamily="34" charset="-122"/>
                 <a:cs typeface="Calibri" pitchFamily="34" charset="-120"/>
               </a:rPr>
-              <a:t>5. Could dispatch use it? A prototype router: about 1–2 points, test it live</a:t>
+              <a:t>5. Could dispatch use it? A prototype router: the mechanism works, the size needs a live test</a:t>
             </a:r>
             <a:endParaRPr lang="en-US" sz="2600" dirty="0"/>
           </a:p>
@@ -8494,7 +8494,7 @@
                 <a:ea typeface="Calibri" pitchFamily="34" charset="-122"/>
                 <a:cs typeface="Calibri" pitchFamily="34" charset="-120"/>
               </a:rPr>
-              <a:t>My own correction</a:t>
+              <a:t>My own correction, twice</a:t>
             </a:r>
             <a:endParaRPr lang="en-US" sz="1300" dirty="0"/>
           </a:p>
@@ -8514,7 +8514,7 @@
                 <a:ea typeface="Calibri" pitchFamily="34" charset="-122"/>
                 <a:cs typeface="Calibri" pitchFamily="34" charset="-120"/>
               </a:rPr>
-              <a:t>First estimate +4 points. A router built on scrambled histories scored itself +4 too, so the model was flattering its choices. Honest range at held workload: +1 to 2.</a:t>
+              <a:t>First estimate +4 points — but a router on scrambled driver histories scored itself +4 too. Capping workload and grading with the other model removed most of that, not all: the scrambled router still scores +1.0 against the real +1.2. What survives is about +0.2 points, and I cannot separate it from zero offline.</a:t>
             </a:r>
             <a:endParaRPr lang="en-US" sz="1300" dirty="0"/>
           </a:p>
@@ -8579,7 +8579,7 @@
                 <a:ea typeface="Calibri" pitchFamily="34" charset="-122"/>
                 <a:cs typeface="Calibri" pitchFamily="34" charset="-120"/>
               </a:rPr>
-              <a:t>Like for like, routing by driver alone also gains about a point; the trip term adds up to a point more, but only by the model that contains it. The router proves the lever is real; the case for matching rests on the held-out test and a driver-visible preference.</a:t>
+              <a:t>Both models share a per-driver effect, and it is the only thing separating candidates on an offer — so they agree about a driver whether or not the history is his. Grade the scrambled routes with the REAL models and the gain drops to zero. The router shows the mechanism; the evidence that the lever exists is the held-out test on slide 7.</a:t>
             </a:r>
             <a:endParaRPr lang="en-US" sz="1300" dirty="0"/>
           </a:p>
@@ -8743,7 +8743,30 @@
                 <a:ea typeface="Calibri" pitchFamily="34" charset="-122"/>
                 <a:cs typeface="Calibri" pitchFamily="34" charset="-120"/>
               </a:rPr>
-              <a:t>Every policy is scored by both models, so none is judged only by the model that chose it.</a:t>
+              <a:t>Every policy is scored by both models, so none is judged only by the model that chose it — but both share a per-driver effect, which is why that guard is partial.</a:t>
+            </a:r>
+            <a:endParaRPr lang="en-US" sz="950" dirty="0"/>
+          </a:p>
+          <a:p>
+            <a:pPr indent="0" marL="0">
+              <a:lnSpc>
+                <a:spcPct val="104000"/>
+              </a:lnSpc>
+              <a:spcAft>
+                <a:spcPts val="500"/>
+              </a:spcAft>
+              <a:buNone/>
+            </a:pPr>
+            <a:r>
+              <a:rPr lang="en-US" sz="1000" dirty="0">
+                <a:solidFill>
+                  <a:srgbClr val="1A1A1A"/>
+                </a:solidFill>
+                <a:latin typeface="Calibri" pitchFamily="34" charset="0"/>
+                <a:ea typeface="Calibri" pitchFamily="34" charset="-122"/>
+                <a:cs typeface="Calibri" pitchFamily="34" charset="-120"/>
+              </a:rPr>
+              <a:t>Null: rebuild the whole router on scrambled driver histories, 20 times, and run it through the same cap and the same grading.</a:t>
             </a:r>
             <a:endParaRPr lang="en-US" sz="950" dirty="0"/>
           </a:p>
@@ -8802,7 +8825,7 @@
                 <a:ea typeface="Calibri" pitchFamily="34" charset="-122"/>
                 <a:cs typeface="Calibri" pitchFamily="34" charset="-120"/>
               </a:rPr>
-              <a:t>2,221 test offers; median 2 candidate drivers; 15% moved under the strict cap, so the 1–2 point average is roughly 8–16 points on the offers that move. Two nested models scored on the same offers: a cautious check. Modelled, not measured.</a:t>
+              <a:t>2,221 test offers; median 2 candidate drivers; 15% moved under the strict cap. Real +1.15 against 20 scrambled rebuilds averaging +0.95 (range +0.72 to +1.15). Modelled offline, not measured; verification/router_checks.py.</a:t>
             </a:r>
             <a:endParaRPr lang="en-US" sz="900" dirty="0"/>
           </a:p>

</xml_diff>